<commit_message>
TL01 Sim-Review: 5 VP + 5 VP-T eingearbeitet + sim_review true
Teilnehmer-Sim (3 TL-Personas) + Trainer-Trainability (Andrea Behrens):
AB-1 Rollenebenen-Tipp + institutioneller Zeitfresser-Anker, AB-2 'Ich weiss
es nicht'-Vorlage, Checkliste Item 6, Reflexionsfrage 4a/4b, L3-Termin im
Ablaufplan, Pause-Ankuendigung AB-2, 2. Kuerzungspfad, Uebergang Merk-Karte,
Trainer-Materialpaket. Workbook/Trainerhandbuch/Deck neu, Validator 0/0.

Co-Authored-By: Claude Opus 4.8 <noreply@anthropic.com>
</commit_message>
<xml_diff>
--- a/protected-downloads/praesentation/TL01.pptx
+++ b/protected-downloads/praesentation/TL01.pptx
@@ -10738,7 +10738,7 @@
                 </a:solidFill>
                 <a:latin typeface="Arial"/>
               </a:rPr>
-              <a:t>  ·  –</a:t>
+              <a:t>  ·  Vor der Pause ankündigen: „Denken Sie in der Pause schon an eine konkrete Aufwärtsdelegations-Situation aus Ihrem Team. Direkt nach der Pause starten wir mit 8 Minuten stiller Vorbereitung auf AB-2."</a:t>
             </a:r>
           </a:p>
           <a:p>
@@ -10923,7 +10923,7 @@
                 </a:solidFill>
                 <a:latin typeface="Arial"/>
               </a:rPr>
-              <a:t>  ·  Feedbackbogen (Sec 6.1) ausfüllen (ca. 6 Min.). Wissenstest (Sec 6.2) als optionale Hausaufgabe ausgeben. Trainer schließt mit einem persönlichen Prüfsatz, der aus den Reflexionsfragen (Sec 4) entstammt: „Was würde sich in Ihrem Team verändern, wenn Sie ab nächster Woche konsequent drei Stunden pro Woche für Führungsarbeit blocken?"</a:t>
+              <a:t>  ·  Feedbackbogen (Sec 6.1) ausfüllen (ca. 6 Min.). Wissenstest (Sec 6.2) als optionale Hausaufgabe ausgeben. Optional, aber wirksam: TN bitten, noch heute den Termin für das Beobachtungsgespräch mit der Bereichsleitung einzutragen (Sec 6.3, L3-Termin-Mechanismus). Trainer schließt mit einem persönlichen Prüfsatz, der aus den Reflexionsfragen (Sec 4) entstammt: „Was würde sich in Ihrem Team verändern, wenn Sie ab nächster Woche konsequent drei Stunden pro Woche für Führungsarbeit blocken?"</a:t>
             </a:r>
           </a:p>
         </p:txBody>

</xml_diff>